<commit_message>
Add experiment 22 (Happiness Focusing Illusion) and apply global markdown quote safety fix
</commit_message>
<xml_diff>
--- a/QR_Esperimenti_Bias.pptx
+++ b/QR_Esperimenti_Bias.pptx
@@ -5,17 +5,17 @@
     <p:sldMasterId id="2147483648" r:id="rId1"/>
   </p:sldMasterIdLst>
   <p:sldIdLst>
-    <p:sldId id="256" r:id="rId7"/>
-    <p:sldId id="257" r:id="rId8"/>
-    <p:sldId id="258" r:id="rId9"/>
-    <p:sldId id="259" r:id="rId10"/>
-    <p:sldId id="260" r:id="rId11"/>
-    <p:sldId id="261" r:id="rId12"/>
-    <p:sldId id="262" r:id="rId13"/>
-    <p:sldId id="263" r:id="rId14"/>
-    <p:sldId id="264" r:id="rId15"/>
-    <p:sldId id="265" r:id="rId16"/>
-    <p:sldId id="266" r:id="rId17"/>
+    <p:sldId id="256" r:id="rId2"/>
+    <p:sldId id="257" r:id="rId3"/>
+    <p:sldId id="258" r:id="rId4"/>
+    <p:sldId id="259" r:id="rId5"/>
+    <p:sldId id="260" r:id="rId6"/>
+    <p:sldId id="261" r:id="rId7"/>
+    <p:sldId id="262" r:id="rId8"/>
+    <p:sldId id="263" r:id="rId9"/>
+    <p:sldId id="264" r:id="rId10"/>
+    <p:sldId id="265" r:id="rId11"/>
+    <p:sldId id="266" r:id="rId12"/>
   </p:sldIdLst>
   <p:sldSz cx="9144000" cy="6858000" type="screen4x3"/>
   <p:notesSz cx="6858000" cy="9144000"/>
@@ -114,6 +114,22 @@
       </a:defRPr>
     </a:lvl9pPr>
   </p:defaultTextStyle>
+  <p:extLst>
+    <p:ext uri="{EFAFB233-063F-42B5-8137-9DF3F51BA10A}">
+      <p15:sldGuideLst xmlns:p15="http://schemas.microsoft.com/office/powerpoint/2012/main">
+        <p15:guide id="1" orient="horz" pos="2160">
+          <p15:clr>
+            <a:srgbClr val="A4A3A4"/>
+          </p15:clr>
+        </p15:guide>
+        <p15:guide id="2" pos="2880">
+          <p15:clr>
+            <a:srgbClr val="A4A3A4"/>
+          </p15:clr>
+        </p15:guide>
+      </p15:sldGuideLst>
+    </p:ext>
+  </p:extLst>
 </p:presentation>
 </file>
 
@@ -155,10 +171,9 @@
           <a:lstStyle/>
           <a:p>
             <a:r>
-              <a:rPr lang="en-US" smtClean="0"/>
+              <a:rPr lang="en-US"/>
               <a:t>Click to edit Master title style</a:t>
             </a:r>
-            <a:endParaRPr lang="en-US"/>
           </a:p>
         </p:txBody>
       </p:sp>
@@ -274,10 +289,9 @@
           </a:lstStyle>
           <a:p>
             <a:r>
-              <a:rPr lang="en-US" smtClean="0"/>
+              <a:rPr lang="en-US"/>
               <a:t>Click to edit Master subtitle style</a:t>
             </a:r>
-            <a:endParaRPr lang="en-US"/>
           </a:p>
         </p:txBody>
       </p:sp>
@@ -298,7 +312,7 @@
           <a:p>
             <a:fld id="{5BCAD085-E8A6-8845-BD4E-CB4CCA059FC4}" type="datetimeFigureOut">
               <a:rPr lang="en-US" smtClean="0"/>
-              <a:t>1/27/13</a:t>
+              <a:t>3/28/2026</a:t>
             </a:fld>
             <a:endParaRPr lang="en-US"/>
           </a:p>
@@ -340,7 +354,7 @@
           <a:p>
             <a:fld id="{C1FF6DA9-008F-8B48-92A6-B652298478BF}" type="slidenum">
               <a:rPr lang="en-US" smtClean="0"/>
-              <a:t>‹#›</a:t>
+              <a:t>‹N›</a:t>
             </a:fld>
             <a:endParaRPr lang="en-US"/>
           </a:p>
@@ -392,10 +406,9 @@
           <a:lstStyle/>
           <a:p>
             <a:r>
-              <a:rPr lang="en-US" smtClean="0"/>
+              <a:rPr lang="en-US"/>
               <a:t>Click to edit Master title style</a:t>
             </a:r>
-            <a:endParaRPr lang="en-US"/>
           </a:p>
         </p:txBody>
       </p:sp>
@@ -416,38 +429,37 @@
           <a:p>
             <a:pPr lvl="0"/>
             <a:r>
-              <a:rPr lang="en-US" smtClean="0"/>
+              <a:rPr lang="en-US"/>
               <a:t>Click to edit Master text styles</a:t>
             </a:r>
           </a:p>
           <a:p>
             <a:pPr lvl="1"/>
             <a:r>
-              <a:rPr lang="en-US" smtClean="0"/>
+              <a:rPr lang="en-US"/>
               <a:t>Second level</a:t>
             </a:r>
           </a:p>
           <a:p>
             <a:pPr lvl="2"/>
             <a:r>
-              <a:rPr lang="en-US" smtClean="0"/>
+              <a:rPr lang="en-US"/>
               <a:t>Third level</a:t>
             </a:r>
           </a:p>
           <a:p>
             <a:pPr lvl="3"/>
             <a:r>
-              <a:rPr lang="en-US" smtClean="0"/>
+              <a:rPr lang="en-US"/>
               <a:t>Fourth level</a:t>
             </a:r>
           </a:p>
           <a:p>
             <a:pPr lvl="4"/>
             <a:r>
-              <a:rPr lang="en-US" smtClean="0"/>
+              <a:rPr lang="en-US"/>
               <a:t>Fifth level</a:t>
             </a:r>
-            <a:endParaRPr lang="en-US"/>
           </a:p>
         </p:txBody>
       </p:sp>
@@ -468,7 +480,7 @@
           <a:p>
             <a:fld id="{5BCAD085-E8A6-8845-BD4E-CB4CCA059FC4}" type="datetimeFigureOut">
               <a:rPr lang="en-US" smtClean="0"/>
-              <a:t>1/27/13</a:t>
+              <a:t>3/28/2026</a:t>
             </a:fld>
             <a:endParaRPr lang="en-US"/>
           </a:p>
@@ -510,7 +522,7 @@
           <a:p>
             <a:fld id="{C1FF6DA9-008F-8B48-92A6-B652298478BF}" type="slidenum">
               <a:rPr lang="en-US" smtClean="0"/>
-              <a:t>‹#›</a:t>
+              <a:t>‹N›</a:t>
             </a:fld>
             <a:endParaRPr lang="en-US"/>
           </a:p>
@@ -567,10 +579,9 @@
           <a:lstStyle/>
           <a:p>
             <a:r>
-              <a:rPr lang="en-US" smtClean="0"/>
+              <a:rPr lang="en-US"/>
               <a:t>Click to edit Master title style</a:t>
             </a:r>
-            <a:endParaRPr lang="en-US"/>
           </a:p>
         </p:txBody>
       </p:sp>
@@ -596,38 +607,37 @@
           <a:p>
             <a:pPr lvl="0"/>
             <a:r>
-              <a:rPr lang="en-US" smtClean="0"/>
+              <a:rPr lang="en-US"/>
               <a:t>Click to edit Master text styles</a:t>
             </a:r>
           </a:p>
           <a:p>
             <a:pPr lvl="1"/>
             <a:r>
-              <a:rPr lang="en-US" smtClean="0"/>
+              <a:rPr lang="en-US"/>
               <a:t>Second level</a:t>
             </a:r>
           </a:p>
           <a:p>
             <a:pPr lvl="2"/>
             <a:r>
-              <a:rPr lang="en-US" smtClean="0"/>
+              <a:rPr lang="en-US"/>
               <a:t>Third level</a:t>
             </a:r>
           </a:p>
           <a:p>
             <a:pPr lvl="3"/>
             <a:r>
-              <a:rPr lang="en-US" smtClean="0"/>
+              <a:rPr lang="en-US"/>
               <a:t>Fourth level</a:t>
             </a:r>
           </a:p>
           <a:p>
             <a:pPr lvl="4"/>
             <a:r>
-              <a:rPr lang="en-US" smtClean="0"/>
+              <a:rPr lang="en-US"/>
               <a:t>Fifth level</a:t>
             </a:r>
-            <a:endParaRPr lang="en-US"/>
           </a:p>
         </p:txBody>
       </p:sp>
@@ -648,7 +658,7 @@
           <a:p>
             <a:fld id="{5BCAD085-E8A6-8845-BD4E-CB4CCA059FC4}" type="datetimeFigureOut">
               <a:rPr lang="en-US" smtClean="0"/>
-              <a:t>1/27/13</a:t>
+              <a:t>3/28/2026</a:t>
             </a:fld>
             <a:endParaRPr lang="en-US"/>
           </a:p>
@@ -690,7 +700,7 @@
           <a:p>
             <a:fld id="{C1FF6DA9-008F-8B48-92A6-B652298478BF}" type="slidenum">
               <a:rPr lang="en-US" smtClean="0"/>
-              <a:t>‹#›</a:t>
+              <a:t>‹N›</a:t>
             </a:fld>
             <a:endParaRPr lang="en-US"/>
           </a:p>
@@ -742,10 +752,9 @@
           <a:lstStyle/>
           <a:p>
             <a:r>
-              <a:rPr lang="en-US" smtClean="0"/>
+              <a:rPr lang="en-US"/>
               <a:t>Click to edit Master title style</a:t>
             </a:r>
-            <a:endParaRPr lang="en-US"/>
           </a:p>
         </p:txBody>
       </p:sp>
@@ -766,38 +775,37 @@
           <a:p>
             <a:pPr lvl="0"/>
             <a:r>
-              <a:rPr lang="en-US" smtClean="0"/>
+              <a:rPr lang="en-US"/>
               <a:t>Click to edit Master text styles</a:t>
             </a:r>
           </a:p>
           <a:p>
             <a:pPr lvl="1"/>
             <a:r>
-              <a:rPr lang="en-US" smtClean="0"/>
+              <a:rPr lang="en-US"/>
               <a:t>Second level</a:t>
             </a:r>
           </a:p>
           <a:p>
             <a:pPr lvl="2"/>
             <a:r>
-              <a:rPr lang="en-US" smtClean="0"/>
+              <a:rPr lang="en-US"/>
               <a:t>Third level</a:t>
             </a:r>
           </a:p>
           <a:p>
             <a:pPr lvl="3"/>
             <a:r>
-              <a:rPr lang="en-US" smtClean="0"/>
+              <a:rPr lang="en-US"/>
               <a:t>Fourth level</a:t>
             </a:r>
           </a:p>
           <a:p>
             <a:pPr lvl="4"/>
             <a:r>
-              <a:rPr lang="en-US" smtClean="0"/>
+              <a:rPr lang="en-US"/>
               <a:t>Fifth level</a:t>
             </a:r>
-            <a:endParaRPr lang="en-US"/>
           </a:p>
         </p:txBody>
       </p:sp>
@@ -818,7 +826,7 @@
           <a:p>
             <a:fld id="{5BCAD085-E8A6-8845-BD4E-CB4CCA059FC4}" type="datetimeFigureOut">
               <a:rPr lang="en-US" smtClean="0"/>
-              <a:t>1/27/13</a:t>
+              <a:t>3/28/2026</a:t>
             </a:fld>
             <a:endParaRPr lang="en-US"/>
           </a:p>
@@ -860,7 +868,7 @@
           <a:p>
             <a:fld id="{C1FF6DA9-008F-8B48-92A6-B652298478BF}" type="slidenum">
               <a:rPr lang="en-US" smtClean="0"/>
-              <a:t>‹#›</a:t>
+              <a:t>‹N›</a:t>
             </a:fld>
             <a:endParaRPr lang="en-US"/>
           </a:p>
@@ -921,10 +929,9 @@
           </a:lstStyle>
           <a:p>
             <a:r>
-              <a:rPr lang="en-US" smtClean="0"/>
+              <a:rPr lang="en-US"/>
               <a:t>Click to edit Master title style</a:t>
             </a:r>
-            <a:endParaRPr lang="en-US"/>
           </a:p>
         </p:txBody>
       </p:sp>
@@ -1041,7 +1048,7 @@
           <a:p>
             <a:pPr lvl="0"/>
             <a:r>
-              <a:rPr lang="en-US" smtClean="0"/>
+              <a:rPr lang="en-US"/>
               <a:t>Click to edit Master text styles</a:t>
             </a:r>
           </a:p>
@@ -1064,7 +1071,7 @@
           <a:p>
             <a:fld id="{5BCAD085-E8A6-8845-BD4E-CB4CCA059FC4}" type="datetimeFigureOut">
               <a:rPr lang="en-US" smtClean="0"/>
-              <a:t>1/27/13</a:t>
+              <a:t>3/28/2026</a:t>
             </a:fld>
             <a:endParaRPr lang="en-US"/>
           </a:p>
@@ -1106,7 +1113,7 @@
           <a:p>
             <a:fld id="{C1FF6DA9-008F-8B48-92A6-B652298478BF}" type="slidenum">
               <a:rPr lang="en-US" smtClean="0"/>
-              <a:t>‹#›</a:t>
+              <a:t>‹N›</a:t>
             </a:fld>
             <a:endParaRPr lang="en-US"/>
           </a:p>
@@ -1158,10 +1165,9 @@
           <a:lstStyle/>
           <a:p>
             <a:r>
-              <a:rPr lang="en-US" smtClean="0"/>
+              <a:rPr lang="en-US"/>
               <a:t>Click to edit Master title style</a:t>
             </a:r>
-            <a:endParaRPr lang="en-US"/>
           </a:p>
         </p:txBody>
       </p:sp>
@@ -1215,38 +1221,37 @@
           <a:p>
             <a:pPr lvl="0"/>
             <a:r>
-              <a:rPr lang="en-US" smtClean="0"/>
+              <a:rPr lang="en-US"/>
               <a:t>Click to edit Master text styles</a:t>
             </a:r>
           </a:p>
           <a:p>
             <a:pPr lvl="1"/>
             <a:r>
-              <a:rPr lang="en-US" smtClean="0"/>
+              <a:rPr lang="en-US"/>
               <a:t>Second level</a:t>
             </a:r>
           </a:p>
           <a:p>
             <a:pPr lvl="2"/>
             <a:r>
-              <a:rPr lang="en-US" smtClean="0"/>
+              <a:rPr lang="en-US"/>
               <a:t>Third level</a:t>
             </a:r>
           </a:p>
           <a:p>
             <a:pPr lvl="3"/>
             <a:r>
-              <a:rPr lang="en-US" smtClean="0"/>
+              <a:rPr lang="en-US"/>
               <a:t>Fourth level</a:t>
             </a:r>
           </a:p>
           <a:p>
             <a:pPr lvl="4"/>
             <a:r>
-              <a:rPr lang="en-US" smtClean="0"/>
+              <a:rPr lang="en-US"/>
               <a:t>Fifth level</a:t>
             </a:r>
-            <a:endParaRPr lang="en-US"/>
           </a:p>
         </p:txBody>
       </p:sp>
@@ -1300,38 +1305,37 @@
           <a:p>
             <a:pPr lvl="0"/>
             <a:r>
-              <a:rPr lang="en-US" smtClean="0"/>
+              <a:rPr lang="en-US"/>
               <a:t>Click to edit Master text styles</a:t>
             </a:r>
           </a:p>
           <a:p>
             <a:pPr lvl="1"/>
             <a:r>
-              <a:rPr lang="en-US" smtClean="0"/>
+              <a:rPr lang="en-US"/>
               <a:t>Second level</a:t>
             </a:r>
           </a:p>
           <a:p>
             <a:pPr lvl="2"/>
             <a:r>
-              <a:rPr lang="en-US" smtClean="0"/>
+              <a:rPr lang="en-US"/>
               <a:t>Third level</a:t>
             </a:r>
           </a:p>
           <a:p>
             <a:pPr lvl="3"/>
             <a:r>
-              <a:rPr lang="en-US" smtClean="0"/>
+              <a:rPr lang="en-US"/>
               <a:t>Fourth level</a:t>
             </a:r>
           </a:p>
           <a:p>
             <a:pPr lvl="4"/>
             <a:r>
-              <a:rPr lang="en-US" smtClean="0"/>
+              <a:rPr lang="en-US"/>
               <a:t>Fifth level</a:t>
             </a:r>
-            <a:endParaRPr lang="en-US"/>
           </a:p>
         </p:txBody>
       </p:sp>
@@ -1352,7 +1356,7 @@
           <a:p>
             <a:fld id="{5BCAD085-E8A6-8845-BD4E-CB4CCA059FC4}" type="datetimeFigureOut">
               <a:rPr lang="en-US" smtClean="0"/>
-              <a:t>1/27/13</a:t>
+              <a:t>3/28/2026</a:t>
             </a:fld>
             <a:endParaRPr lang="en-US"/>
           </a:p>
@@ -1394,7 +1398,7 @@
           <a:p>
             <a:fld id="{C1FF6DA9-008F-8B48-92A6-B652298478BF}" type="slidenum">
               <a:rPr lang="en-US" smtClean="0"/>
-              <a:t>‹#›</a:t>
+              <a:t>‹N›</a:t>
             </a:fld>
             <a:endParaRPr lang="en-US"/>
           </a:p>
@@ -1450,10 +1454,9 @@
           </a:lstStyle>
           <a:p>
             <a:r>
-              <a:rPr lang="en-US" smtClean="0"/>
+              <a:rPr lang="en-US"/>
               <a:t>Click to edit Master title style</a:t>
             </a:r>
-            <a:endParaRPr lang="en-US"/>
           </a:p>
         </p:txBody>
       </p:sp>
@@ -1516,7 +1519,7 @@
           <a:p>
             <a:pPr lvl="0"/>
             <a:r>
-              <a:rPr lang="en-US" smtClean="0"/>
+              <a:rPr lang="en-US"/>
               <a:t>Click to edit Master text styles</a:t>
             </a:r>
           </a:p>
@@ -1572,38 +1575,37 @@
           <a:p>
             <a:pPr lvl="0"/>
             <a:r>
-              <a:rPr lang="en-US" smtClean="0"/>
+              <a:rPr lang="en-US"/>
               <a:t>Click to edit Master text styles</a:t>
             </a:r>
           </a:p>
           <a:p>
             <a:pPr lvl="1"/>
             <a:r>
-              <a:rPr lang="en-US" smtClean="0"/>
+              <a:rPr lang="en-US"/>
               <a:t>Second level</a:t>
             </a:r>
           </a:p>
           <a:p>
             <a:pPr lvl="2"/>
             <a:r>
-              <a:rPr lang="en-US" smtClean="0"/>
+              <a:rPr lang="en-US"/>
               <a:t>Third level</a:t>
             </a:r>
           </a:p>
           <a:p>
             <a:pPr lvl="3"/>
             <a:r>
-              <a:rPr lang="en-US" smtClean="0"/>
+              <a:rPr lang="en-US"/>
               <a:t>Fourth level</a:t>
             </a:r>
           </a:p>
           <a:p>
             <a:pPr lvl="4"/>
             <a:r>
-              <a:rPr lang="en-US" smtClean="0"/>
+              <a:rPr lang="en-US"/>
               <a:t>Fifth level</a:t>
             </a:r>
-            <a:endParaRPr lang="en-US"/>
           </a:p>
         </p:txBody>
       </p:sp>
@@ -1666,7 +1668,7 @@
           <a:p>
             <a:pPr lvl="0"/>
             <a:r>
-              <a:rPr lang="en-US" smtClean="0"/>
+              <a:rPr lang="en-US"/>
               <a:t>Click to edit Master text styles</a:t>
             </a:r>
           </a:p>
@@ -1722,38 +1724,37 @@
           <a:p>
             <a:pPr lvl="0"/>
             <a:r>
-              <a:rPr lang="en-US" smtClean="0"/>
+              <a:rPr lang="en-US"/>
               <a:t>Click to edit Master text styles</a:t>
             </a:r>
           </a:p>
           <a:p>
             <a:pPr lvl="1"/>
             <a:r>
-              <a:rPr lang="en-US" smtClean="0"/>
+              <a:rPr lang="en-US"/>
               <a:t>Second level</a:t>
             </a:r>
           </a:p>
           <a:p>
             <a:pPr lvl="2"/>
             <a:r>
-              <a:rPr lang="en-US" smtClean="0"/>
+              <a:rPr lang="en-US"/>
               <a:t>Third level</a:t>
             </a:r>
           </a:p>
           <a:p>
             <a:pPr lvl="3"/>
             <a:r>
-              <a:rPr lang="en-US" smtClean="0"/>
+              <a:rPr lang="en-US"/>
               <a:t>Fourth level</a:t>
             </a:r>
           </a:p>
           <a:p>
             <a:pPr lvl="4"/>
             <a:r>
-              <a:rPr lang="en-US" smtClean="0"/>
+              <a:rPr lang="en-US"/>
               <a:t>Fifth level</a:t>
             </a:r>
-            <a:endParaRPr lang="en-US"/>
           </a:p>
         </p:txBody>
       </p:sp>
@@ -1774,7 +1775,7 @@
           <a:p>
             <a:fld id="{5BCAD085-E8A6-8845-BD4E-CB4CCA059FC4}" type="datetimeFigureOut">
               <a:rPr lang="en-US" smtClean="0"/>
-              <a:t>1/27/13</a:t>
+              <a:t>3/28/2026</a:t>
             </a:fld>
             <a:endParaRPr lang="en-US"/>
           </a:p>
@@ -1816,7 +1817,7 @@
           <a:p>
             <a:fld id="{C1FF6DA9-008F-8B48-92A6-B652298478BF}" type="slidenum">
               <a:rPr lang="en-US" smtClean="0"/>
-              <a:t>‹#›</a:t>
+              <a:t>‹N›</a:t>
             </a:fld>
             <a:endParaRPr lang="en-US"/>
           </a:p>
@@ -1868,10 +1869,9 @@
           <a:lstStyle/>
           <a:p>
             <a:r>
-              <a:rPr lang="en-US" smtClean="0"/>
+              <a:rPr lang="en-US"/>
               <a:t>Click to edit Master title style</a:t>
             </a:r>
-            <a:endParaRPr lang="en-US"/>
           </a:p>
         </p:txBody>
       </p:sp>
@@ -1892,7 +1892,7 @@
           <a:p>
             <a:fld id="{5BCAD085-E8A6-8845-BD4E-CB4CCA059FC4}" type="datetimeFigureOut">
               <a:rPr lang="en-US" smtClean="0"/>
-              <a:t>1/27/13</a:t>
+              <a:t>3/28/2026</a:t>
             </a:fld>
             <a:endParaRPr lang="en-US"/>
           </a:p>
@@ -1934,7 +1934,7 @@
           <a:p>
             <a:fld id="{C1FF6DA9-008F-8B48-92A6-B652298478BF}" type="slidenum">
               <a:rPr lang="en-US" smtClean="0"/>
-              <a:t>‹#›</a:t>
+              <a:t>‹N›</a:t>
             </a:fld>
             <a:endParaRPr lang="en-US"/>
           </a:p>
@@ -1987,7 +1987,7 @@
           <a:p>
             <a:fld id="{5BCAD085-E8A6-8845-BD4E-CB4CCA059FC4}" type="datetimeFigureOut">
               <a:rPr lang="en-US" smtClean="0"/>
-              <a:t>1/27/13</a:t>
+              <a:t>3/28/2026</a:t>
             </a:fld>
             <a:endParaRPr lang="en-US"/>
           </a:p>
@@ -2029,7 +2029,7 @@
           <a:p>
             <a:fld id="{C1FF6DA9-008F-8B48-92A6-B652298478BF}" type="slidenum">
               <a:rPr lang="en-US" smtClean="0"/>
-              <a:t>‹#›</a:t>
+              <a:t>‹N›</a:t>
             </a:fld>
             <a:endParaRPr lang="en-US"/>
           </a:p>
@@ -2090,10 +2090,9 @@
           </a:lstStyle>
           <a:p>
             <a:r>
-              <a:rPr lang="en-US" smtClean="0"/>
+              <a:rPr lang="en-US"/>
               <a:t>Click to edit Master title style</a:t>
             </a:r>
-            <a:endParaRPr lang="en-US"/>
           </a:p>
         </p:txBody>
       </p:sp>
@@ -2147,38 +2146,37 @@
           <a:p>
             <a:pPr lvl="0"/>
             <a:r>
-              <a:rPr lang="en-US" smtClean="0"/>
+              <a:rPr lang="en-US"/>
               <a:t>Click to edit Master text styles</a:t>
             </a:r>
           </a:p>
           <a:p>
             <a:pPr lvl="1"/>
             <a:r>
-              <a:rPr lang="en-US" smtClean="0"/>
+              <a:rPr lang="en-US"/>
               <a:t>Second level</a:t>
             </a:r>
           </a:p>
           <a:p>
             <a:pPr lvl="2"/>
             <a:r>
-              <a:rPr lang="en-US" smtClean="0"/>
+              <a:rPr lang="en-US"/>
               <a:t>Third level</a:t>
             </a:r>
           </a:p>
           <a:p>
             <a:pPr lvl="3"/>
             <a:r>
-              <a:rPr lang="en-US" smtClean="0"/>
+              <a:rPr lang="en-US"/>
               <a:t>Fourth level</a:t>
             </a:r>
           </a:p>
           <a:p>
             <a:pPr lvl="4"/>
             <a:r>
-              <a:rPr lang="en-US" smtClean="0"/>
+              <a:rPr lang="en-US"/>
               <a:t>Fifth level</a:t>
             </a:r>
-            <a:endParaRPr lang="en-US"/>
           </a:p>
         </p:txBody>
       </p:sp>
@@ -2241,7 +2239,7 @@
           <a:p>
             <a:pPr lvl="0"/>
             <a:r>
-              <a:rPr lang="en-US" smtClean="0"/>
+              <a:rPr lang="en-US"/>
               <a:t>Click to edit Master text styles</a:t>
             </a:r>
           </a:p>
@@ -2264,7 +2262,7 @@
           <a:p>
             <a:fld id="{5BCAD085-E8A6-8845-BD4E-CB4CCA059FC4}" type="datetimeFigureOut">
               <a:rPr lang="en-US" smtClean="0"/>
-              <a:t>1/27/13</a:t>
+              <a:t>3/28/2026</a:t>
             </a:fld>
             <a:endParaRPr lang="en-US"/>
           </a:p>
@@ -2306,7 +2304,7 @@
           <a:p>
             <a:fld id="{C1FF6DA9-008F-8B48-92A6-B652298478BF}" type="slidenum">
               <a:rPr lang="en-US" smtClean="0"/>
-              <a:t>‹#›</a:t>
+              <a:t>‹N›</a:t>
             </a:fld>
             <a:endParaRPr lang="en-US"/>
           </a:p>
@@ -2367,10 +2365,9 @@
           </a:lstStyle>
           <a:p>
             <a:r>
-              <a:rPr lang="en-US" smtClean="0"/>
+              <a:rPr lang="en-US"/>
               <a:t>Click to edit Master title style</a:t>
             </a:r>
-            <a:endParaRPr lang="en-US"/>
           </a:p>
         </p:txBody>
       </p:sp>
@@ -2494,7 +2491,7 @@
           <a:p>
             <a:pPr lvl="0"/>
             <a:r>
-              <a:rPr lang="en-US" smtClean="0"/>
+              <a:rPr lang="en-US"/>
               <a:t>Click to edit Master text styles</a:t>
             </a:r>
           </a:p>
@@ -2517,7 +2514,7 @@
           <a:p>
             <a:fld id="{5BCAD085-E8A6-8845-BD4E-CB4CCA059FC4}" type="datetimeFigureOut">
               <a:rPr lang="en-US" smtClean="0"/>
-              <a:t>1/27/13</a:t>
+              <a:t>3/28/2026</a:t>
             </a:fld>
             <a:endParaRPr lang="en-US"/>
           </a:p>
@@ -2559,7 +2556,7 @@
           <a:p>
             <a:fld id="{C1FF6DA9-008F-8B48-92A6-B652298478BF}" type="slidenum">
               <a:rPr lang="en-US" smtClean="0"/>
-              <a:t>‹#›</a:t>
+              <a:t>‹N›</a:t>
             </a:fld>
             <a:endParaRPr lang="en-US"/>
           </a:p>
@@ -2626,10 +2623,9 @@
           <a:lstStyle/>
           <a:p>
             <a:r>
-              <a:rPr lang="en-US" smtClean="0"/>
+              <a:rPr lang="en-US"/>
               <a:t>Click to edit Master title style</a:t>
             </a:r>
-            <a:endParaRPr lang="en-US"/>
           </a:p>
         </p:txBody>
       </p:sp>
@@ -2660,38 +2656,37 @@
           <a:p>
             <a:pPr lvl="0"/>
             <a:r>
-              <a:rPr lang="en-US" smtClean="0"/>
+              <a:rPr lang="en-US"/>
               <a:t>Click to edit Master text styles</a:t>
             </a:r>
           </a:p>
           <a:p>
             <a:pPr lvl="1"/>
             <a:r>
-              <a:rPr lang="en-US" smtClean="0"/>
+              <a:rPr lang="en-US"/>
               <a:t>Second level</a:t>
             </a:r>
           </a:p>
           <a:p>
             <a:pPr lvl="2"/>
             <a:r>
-              <a:rPr lang="en-US" smtClean="0"/>
+              <a:rPr lang="en-US"/>
               <a:t>Third level</a:t>
             </a:r>
           </a:p>
           <a:p>
             <a:pPr lvl="3"/>
             <a:r>
-              <a:rPr lang="en-US" smtClean="0"/>
+              <a:rPr lang="en-US"/>
               <a:t>Fourth level</a:t>
             </a:r>
           </a:p>
           <a:p>
             <a:pPr lvl="4"/>
             <a:r>
-              <a:rPr lang="en-US" smtClean="0"/>
+              <a:rPr lang="en-US"/>
               <a:t>Fifth level</a:t>
             </a:r>
-            <a:endParaRPr lang="en-US"/>
           </a:p>
         </p:txBody>
       </p:sp>
@@ -2730,7 +2725,7 @@
           <a:p>
             <a:fld id="{5BCAD085-E8A6-8845-BD4E-CB4CCA059FC4}" type="datetimeFigureOut">
               <a:rPr lang="en-US" smtClean="0"/>
-              <a:t>1/27/13</a:t>
+              <a:t>3/28/2026</a:t>
             </a:fld>
             <a:endParaRPr lang="en-US"/>
           </a:p>
@@ -2808,7 +2803,7 @@
           <a:p>
             <a:fld id="{C1FF6DA9-008F-8B48-92A6-B652298478BF}" type="slidenum">
               <a:rPr lang="en-US" smtClean="0"/>
-              <a:t>‹#›</a:t>
+              <a:t>‹N›</a:t>
             </a:fld>
             <a:endParaRPr lang="en-US"/>
           </a:p>
@@ -3089,7 +3084,7 @@
 </file>
 
 <file path=ppt/slides/slide1.xml><?xml version="1.0" encoding="utf-8"?>
-<p:sld xmlns:a="http://schemas.openxmlformats.org/drawingml/2006/main" xmlns:p="http://schemas.openxmlformats.org/presentationml/2006/main" xmlns:r="http://schemas.openxmlformats.org/officeDocument/2006/relationships">
+<p:sld xmlns:a="http://schemas.openxmlformats.org/drawingml/2006/main" xmlns:r="http://schemas.openxmlformats.org/officeDocument/2006/relationships" xmlns:p="http://schemas.openxmlformats.org/presentationml/2006/main">
   <p:cSld>
     <p:spTree>
       <p:nvGrpSpPr>
@@ -3097,7 +3092,14 @@
         <p:cNvGrpSpPr/>
         <p:nvPr/>
       </p:nvGrpSpPr>
-      <p:grpSpPr/>
+      <p:grpSpPr>
+        <a:xfrm>
+          <a:off x="0" y="0"/>
+          <a:ext cx="0" cy="0"/>
+          <a:chOff x="0" y="0"/>
+          <a:chExt cx="0" cy="0"/>
+        </a:xfrm>
+      </p:grpSpPr>
       <p:sp>
         <p:nvSpPr>
           <p:cNvPr id="2" name="Title 1"/>
@@ -3114,8 +3116,26 @@
           <a:lstStyle/>
           <a:p>
             <a:r>
-              <a:t>Lezione Interattiva sui Bias Cognitivi</a:t>
-            </a:r>
+              <a:rPr dirty="0" err="1"/>
+              <a:t>Lezione</a:t>
+            </a:r>
+            <a:r>
+              <a:rPr dirty="0"/>
+              <a:t> </a:t>
+            </a:r>
+            <a:r>
+              <a:rPr dirty="0" err="1"/>
+              <a:t>Interattiva</a:t>
+            </a:r>
+            <a:r>
+              <a:rPr dirty="0"/>
+              <a:t> sui Bias </a:t>
+            </a:r>
+            <a:r>
+              <a:rPr dirty="0" err="1"/>
+              <a:t>Cognitivi</a:t>
+            </a:r>
+            <a:endParaRPr dirty="0"/>
           </a:p>
         </p:txBody>
       </p:sp>
@@ -3134,14 +3154,7 @@
           <a:bodyPr/>
           <a:lstStyle/>
           <a:p>
-            <a:r>
-              <a:t>Inquadra i QR code per partecipare!</a:t>
-            </a:r>
-          </a:p>
-          <a:p>
-            <a:r>
-              <a:t>(Generati automaticamente da IA)</a:t>
-            </a:r>
+            <a:endParaRPr dirty="0"/>
           </a:p>
         </p:txBody>
       </p:sp>
@@ -3154,7 +3167,7 @@
 </file>
 
 <file path=ppt/slides/slide10.xml><?xml version="1.0" encoding="utf-8"?>
-<p:sld xmlns:a="http://schemas.openxmlformats.org/drawingml/2006/main" xmlns:p="http://schemas.openxmlformats.org/presentationml/2006/main" xmlns:r="http://schemas.openxmlformats.org/officeDocument/2006/relationships">
+<p:sld xmlns:a="http://schemas.openxmlformats.org/drawingml/2006/main" xmlns:r="http://schemas.openxmlformats.org/officeDocument/2006/relationships" xmlns:p="http://schemas.openxmlformats.org/presentationml/2006/main">
   <p:cSld>
     <p:spTree>
       <p:nvGrpSpPr>
@@ -3162,7 +3175,14 @@
         <p:cNvGrpSpPr/>
         <p:nvPr/>
       </p:nvGrpSpPr>
-      <p:grpSpPr/>
+      <p:grpSpPr>
+        <a:xfrm>
+          <a:off x="0" y="0"/>
+          <a:ext cx="0" cy="0"/>
+          <a:chOff x="0" y="0"/>
+          <a:chExt cx="0" cy="0"/>
+        </a:xfrm>
+      </p:grpSpPr>
       <p:sp>
         <p:nvSpPr>
           <p:cNvPr id="2" name="Title 1"/>
@@ -3198,7 +3218,9 @@
         <p:txBody>
           <a:bodyPr/>
           <a:lstStyle/>
-          <a:p/>
+          <a:p>
+            <a:endParaRPr/>
+          </a:p>
         </p:txBody>
       </p:sp>
       <p:pic>
@@ -3248,6 +3270,7 @@
           <a:lstStyle/>
           <a:p>
             <a:pPr algn="ctr"/>
+            <a:endParaRPr/>
           </a:p>
           <a:p>
             <a:pPr>
@@ -3272,7 +3295,7 @@
 </file>
 
 <file path=ppt/slides/slide11.xml><?xml version="1.0" encoding="utf-8"?>
-<p:sld xmlns:a="http://schemas.openxmlformats.org/drawingml/2006/main" xmlns:p="http://schemas.openxmlformats.org/presentationml/2006/main" xmlns:r="http://schemas.openxmlformats.org/officeDocument/2006/relationships">
+<p:sld xmlns:a="http://schemas.openxmlformats.org/drawingml/2006/main" xmlns:r="http://schemas.openxmlformats.org/officeDocument/2006/relationships" xmlns:p="http://schemas.openxmlformats.org/presentationml/2006/main">
   <p:cSld>
     <p:spTree>
       <p:nvGrpSpPr>
@@ -3280,7 +3303,14 @@
         <p:cNvGrpSpPr/>
         <p:nvPr/>
       </p:nvGrpSpPr>
-      <p:grpSpPr/>
+      <p:grpSpPr>
+        <a:xfrm>
+          <a:off x="0" y="0"/>
+          <a:ext cx="0" cy="0"/>
+          <a:chOff x="0" y="0"/>
+          <a:chExt cx="0" cy="0"/>
+        </a:xfrm>
+      </p:grpSpPr>
       <p:sp>
         <p:nvSpPr>
           <p:cNvPr id="2" name="Title 1"/>
@@ -3316,7 +3346,9 @@
         <p:txBody>
           <a:bodyPr/>
           <a:lstStyle/>
-          <a:p/>
+          <a:p>
+            <a:endParaRPr/>
+          </a:p>
         </p:txBody>
       </p:sp>
       <p:pic>
@@ -3366,6 +3398,7 @@
           <a:lstStyle/>
           <a:p>
             <a:pPr algn="ctr"/>
+            <a:endParaRPr/>
           </a:p>
           <a:p>
             <a:pPr>
@@ -3390,7 +3423,7 @@
 </file>
 
 <file path=ppt/slides/slide2.xml><?xml version="1.0" encoding="utf-8"?>
-<p:sld xmlns:a="http://schemas.openxmlformats.org/drawingml/2006/main" xmlns:p="http://schemas.openxmlformats.org/presentationml/2006/main" xmlns:r="http://schemas.openxmlformats.org/officeDocument/2006/relationships">
+<p:sld xmlns:a="http://schemas.openxmlformats.org/drawingml/2006/main" xmlns:r="http://schemas.openxmlformats.org/officeDocument/2006/relationships" xmlns:p="http://schemas.openxmlformats.org/presentationml/2006/main">
   <p:cSld>
     <p:spTree>
       <p:nvGrpSpPr>
@@ -3398,7 +3431,14 @@
         <p:cNvGrpSpPr/>
         <p:nvPr/>
       </p:nvGrpSpPr>
-      <p:grpSpPr/>
+      <p:grpSpPr>
+        <a:xfrm>
+          <a:off x="0" y="0"/>
+          <a:ext cx="0" cy="0"/>
+          <a:chOff x="0" y="0"/>
+          <a:chExt cx="0" cy="0"/>
+        </a:xfrm>
+      </p:grpSpPr>
       <p:sp>
         <p:nvSpPr>
           <p:cNvPr id="2" name="Title 1"/>
@@ -3434,7 +3474,9 @@
         <p:txBody>
           <a:bodyPr/>
           <a:lstStyle/>
-          <a:p/>
+          <a:p>
+            <a:endParaRPr/>
+          </a:p>
         </p:txBody>
       </p:sp>
       <p:pic>
@@ -3484,6 +3526,7 @@
           <a:lstStyle/>
           <a:p>
             <a:pPr algn="ctr"/>
+            <a:endParaRPr/>
           </a:p>
           <a:p>
             <a:pPr>
@@ -3508,7 +3551,7 @@
 </file>
 
 <file path=ppt/slides/slide3.xml><?xml version="1.0" encoding="utf-8"?>
-<p:sld xmlns:a="http://schemas.openxmlformats.org/drawingml/2006/main" xmlns:p="http://schemas.openxmlformats.org/presentationml/2006/main" xmlns:r="http://schemas.openxmlformats.org/officeDocument/2006/relationships">
+<p:sld xmlns:a="http://schemas.openxmlformats.org/drawingml/2006/main" xmlns:r="http://schemas.openxmlformats.org/officeDocument/2006/relationships" xmlns:p="http://schemas.openxmlformats.org/presentationml/2006/main">
   <p:cSld>
     <p:spTree>
       <p:nvGrpSpPr>
@@ -3516,7 +3559,14 @@
         <p:cNvGrpSpPr/>
         <p:nvPr/>
       </p:nvGrpSpPr>
-      <p:grpSpPr/>
+      <p:grpSpPr>
+        <a:xfrm>
+          <a:off x="0" y="0"/>
+          <a:ext cx="0" cy="0"/>
+          <a:chOff x="0" y="0"/>
+          <a:chExt cx="0" cy="0"/>
+        </a:xfrm>
+      </p:grpSpPr>
       <p:sp>
         <p:nvSpPr>
           <p:cNvPr id="2" name="Title 1"/>
@@ -3552,7 +3602,9 @@
         <p:txBody>
           <a:bodyPr/>
           <a:lstStyle/>
-          <a:p/>
+          <a:p>
+            <a:endParaRPr/>
+          </a:p>
         </p:txBody>
       </p:sp>
       <p:pic>
@@ -3602,6 +3654,7 @@
           <a:lstStyle/>
           <a:p>
             <a:pPr algn="ctr"/>
+            <a:endParaRPr/>
           </a:p>
           <a:p>
             <a:pPr>
@@ -3626,7 +3679,7 @@
 </file>
 
 <file path=ppt/slides/slide4.xml><?xml version="1.0" encoding="utf-8"?>
-<p:sld xmlns:a="http://schemas.openxmlformats.org/drawingml/2006/main" xmlns:p="http://schemas.openxmlformats.org/presentationml/2006/main" xmlns:r="http://schemas.openxmlformats.org/officeDocument/2006/relationships">
+<p:sld xmlns:a="http://schemas.openxmlformats.org/drawingml/2006/main" xmlns:r="http://schemas.openxmlformats.org/officeDocument/2006/relationships" xmlns:p="http://schemas.openxmlformats.org/presentationml/2006/main">
   <p:cSld>
     <p:spTree>
       <p:nvGrpSpPr>
@@ -3634,7 +3687,14 @@
         <p:cNvGrpSpPr/>
         <p:nvPr/>
       </p:nvGrpSpPr>
-      <p:grpSpPr/>
+      <p:grpSpPr>
+        <a:xfrm>
+          <a:off x="0" y="0"/>
+          <a:ext cx="0" cy="0"/>
+          <a:chOff x="0" y="0"/>
+          <a:chExt cx="0" cy="0"/>
+        </a:xfrm>
+      </p:grpSpPr>
       <p:sp>
         <p:nvSpPr>
           <p:cNvPr id="2" name="Title 1"/>
@@ -3670,7 +3730,9 @@
         <p:txBody>
           <a:bodyPr/>
           <a:lstStyle/>
-          <a:p/>
+          <a:p>
+            <a:endParaRPr/>
+          </a:p>
         </p:txBody>
       </p:sp>
       <p:pic>
@@ -3720,6 +3782,7 @@
           <a:lstStyle/>
           <a:p>
             <a:pPr algn="ctr"/>
+            <a:endParaRPr/>
           </a:p>
           <a:p>
             <a:pPr>
@@ -3744,7 +3807,7 @@
 </file>
 
 <file path=ppt/slides/slide5.xml><?xml version="1.0" encoding="utf-8"?>
-<p:sld xmlns:a="http://schemas.openxmlformats.org/drawingml/2006/main" xmlns:p="http://schemas.openxmlformats.org/presentationml/2006/main" xmlns:r="http://schemas.openxmlformats.org/officeDocument/2006/relationships">
+<p:sld xmlns:a="http://schemas.openxmlformats.org/drawingml/2006/main" xmlns:r="http://schemas.openxmlformats.org/officeDocument/2006/relationships" xmlns:p="http://schemas.openxmlformats.org/presentationml/2006/main">
   <p:cSld>
     <p:spTree>
       <p:nvGrpSpPr>
@@ -3752,7 +3815,14 @@
         <p:cNvGrpSpPr/>
         <p:nvPr/>
       </p:nvGrpSpPr>
-      <p:grpSpPr/>
+      <p:grpSpPr>
+        <a:xfrm>
+          <a:off x="0" y="0"/>
+          <a:ext cx="0" cy="0"/>
+          <a:chOff x="0" y="0"/>
+          <a:chExt cx="0" cy="0"/>
+        </a:xfrm>
+      </p:grpSpPr>
       <p:sp>
         <p:nvSpPr>
           <p:cNvPr id="2" name="Title 1"/>
@@ -3788,7 +3858,9 @@
         <p:txBody>
           <a:bodyPr/>
           <a:lstStyle/>
-          <a:p/>
+          <a:p>
+            <a:endParaRPr/>
+          </a:p>
         </p:txBody>
       </p:sp>
       <p:pic>
@@ -3838,6 +3910,7 @@
           <a:lstStyle/>
           <a:p>
             <a:pPr algn="ctr"/>
+            <a:endParaRPr/>
           </a:p>
           <a:p>
             <a:pPr>
@@ -3862,7 +3935,7 @@
 </file>
 
 <file path=ppt/slides/slide6.xml><?xml version="1.0" encoding="utf-8"?>
-<p:sld xmlns:a="http://schemas.openxmlformats.org/drawingml/2006/main" xmlns:p="http://schemas.openxmlformats.org/presentationml/2006/main" xmlns:r="http://schemas.openxmlformats.org/officeDocument/2006/relationships">
+<p:sld xmlns:a="http://schemas.openxmlformats.org/drawingml/2006/main" xmlns:r="http://schemas.openxmlformats.org/officeDocument/2006/relationships" xmlns:p="http://schemas.openxmlformats.org/presentationml/2006/main">
   <p:cSld>
     <p:spTree>
       <p:nvGrpSpPr>
@@ -3870,7 +3943,14 @@
         <p:cNvGrpSpPr/>
         <p:nvPr/>
       </p:nvGrpSpPr>
-      <p:grpSpPr/>
+      <p:grpSpPr>
+        <a:xfrm>
+          <a:off x="0" y="0"/>
+          <a:ext cx="0" cy="0"/>
+          <a:chOff x="0" y="0"/>
+          <a:chExt cx="0" cy="0"/>
+        </a:xfrm>
+      </p:grpSpPr>
       <p:sp>
         <p:nvSpPr>
           <p:cNvPr id="2" name="Title 1"/>
@@ -3906,7 +3986,9 @@
         <p:txBody>
           <a:bodyPr/>
           <a:lstStyle/>
-          <a:p/>
+          <a:p>
+            <a:endParaRPr/>
+          </a:p>
         </p:txBody>
       </p:sp>
       <p:pic>
@@ -3956,6 +4038,7 @@
           <a:lstStyle/>
           <a:p>
             <a:pPr algn="ctr"/>
+            <a:endParaRPr/>
           </a:p>
           <a:p>
             <a:pPr>
@@ -3980,7 +4063,7 @@
 </file>
 
 <file path=ppt/slides/slide7.xml><?xml version="1.0" encoding="utf-8"?>
-<p:sld xmlns:a="http://schemas.openxmlformats.org/drawingml/2006/main" xmlns:p="http://schemas.openxmlformats.org/presentationml/2006/main" xmlns:r="http://schemas.openxmlformats.org/officeDocument/2006/relationships">
+<p:sld xmlns:a="http://schemas.openxmlformats.org/drawingml/2006/main" xmlns:r="http://schemas.openxmlformats.org/officeDocument/2006/relationships" xmlns:p="http://schemas.openxmlformats.org/presentationml/2006/main">
   <p:cSld>
     <p:spTree>
       <p:nvGrpSpPr>
@@ -3988,7 +4071,14 @@
         <p:cNvGrpSpPr/>
         <p:nvPr/>
       </p:nvGrpSpPr>
-      <p:grpSpPr/>
+      <p:grpSpPr>
+        <a:xfrm>
+          <a:off x="0" y="0"/>
+          <a:ext cx="0" cy="0"/>
+          <a:chOff x="0" y="0"/>
+          <a:chExt cx="0" cy="0"/>
+        </a:xfrm>
+      </p:grpSpPr>
       <p:sp>
         <p:nvSpPr>
           <p:cNvPr id="2" name="Title 1"/>
@@ -4024,7 +4114,9 @@
         <p:txBody>
           <a:bodyPr/>
           <a:lstStyle/>
-          <a:p/>
+          <a:p>
+            <a:endParaRPr/>
+          </a:p>
         </p:txBody>
       </p:sp>
       <p:pic>
@@ -4074,6 +4166,7 @@
           <a:lstStyle/>
           <a:p>
             <a:pPr algn="ctr"/>
+            <a:endParaRPr/>
           </a:p>
           <a:p>
             <a:pPr>
@@ -4098,7 +4191,7 @@
 </file>
 
 <file path=ppt/slides/slide8.xml><?xml version="1.0" encoding="utf-8"?>
-<p:sld xmlns:a="http://schemas.openxmlformats.org/drawingml/2006/main" xmlns:p="http://schemas.openxmlformats.org/presentationml/2006/main" xmlns:r="http://schemas.openxmlformats.org/officeDocument/2006/relationships">
+<p:sld xmlns:a="http://schemas.openxmlformats.org/drawingml/2006/main" xmlns:r="http://schemas.openxmlformats.org/officeDocument/2006/relationships" xmlns:p="http://schemas.openxmlformats.org/presentationml/2006/main">
   <p:cSld>
     <p:spTree>
       <p:nvGrpSpPr>
@@ -4106,7 +4199,14 @@
         <p:cNvGrpSpPr/>
         <p:nvPr/>
       </p:nvGrpSpPr>
-      <p:grpSpPr/>
+      <p:grpSpPr>
+        <a:xfrm>
+          <a:off x="0" y="0"/>
+          <a:ext cx="0" cy="0"/>
+          <a:chOff x="0" y="0"/>
+          <a:chExt cx="0" cy="0"/>
+        </a:xfrm>
+      </p:grpSpPr>
       <p:sp>
         <p:nvSpPr>
           <p:cNvPr id="2" name="Title 1"/>
@@ -4142,7 +4242,9 @@
         <p:txBody>
           <a:bodyPr/>
           <a:lstStyle/>
-          <a:p/>
+          <a:p>
+            <a:endParaRPr/>
+          </a:p>
         </p:txBody>
       </p:sp>
       <p:pic>
@@ -4192,6 +4294,7 @@
           <a:lstStyle/>
           <a:p>
             <a:pPr algn="ctr"/>
+            <a:endParaRPr/>
           </a:p>
           <a:p>
             <a:pPr>
@@ -4216,7 +4319,7 @@
 </file>
 
 <file path=ppt/slides/slide9.xml><?xml version="1.0" encoding="utf-8"?>
-<p:sld xmlns:a="http://schemas.openxmlformats.org/drawingml/2006/main" xmlns:p="http://schemas.openxmlformats.org/presentationml/2006/main" xmlns:r="http://schemas.openxmlformats.org/officeDocument/2006/relationships">
+<p:sld xmlns:a="http://schemas.openxmlformats.org/drawingml/2006/main" xmlns:r="http://schemas.openxmlformats.org/officeDocument/2006/relationships" xmlns:p="http://schemas.openxmlformats.org/presentationml/2006/main">
   <p:cSld>
     <p:spTree>
       <p:nvGrpSpPr>
@@ -4224,7 +4327,14 @@
         <p:cNvGrpSpPr/>
         <p:nvPr/>
       </p:nvGrpSpPr>
-      <p:grpSpPr/>
+      <p:grpSpPr>
+        <a:xfrm>
+          <a:off x="0" y="0"/>
+          <a:ext cx="0" cy="0"/>
+          <a:chOff x="0" y="0"/>
+          <a:chExt cx="0" cy="0"/>
+        </a:xfrm>
+      </p:grpSpPr>
       <p:sp>
         <p:nvSpPr>
           <p:cNvPr id="2" name="Title 1"/>
@@ -4260,7 +4370,9 @@
         <p:txBody>
           <a:bodyPr/>
           <a:lstStyle/>
-          <a:p/>
+          <a:p>
+            <a:endParaRPr/>
+          </a:p>
         </p:txBody>
       </p:sp>
       <p:pic>
@@ -4310,6 +4422,7 @@
           <a:lstStyle/>
           <a:p>
             <a:pPr algn="ctr"/>
+            <a:endParaRPr/>
           </a:p>
           <a:p>
             <a:pPr>

</xml_diff>